<commit_message>
Noite 2: aquecimento em Python no notebook do Databricks, antes do terminal
- A API dos feriados sai do Claude Code e vira o aquecimento: 4 células num
  notebook serverless (extrair com requests, pousar no volume, read_files,
  conferir), testado no serverless; notebook pronto para importar por URL
- Saem o prompt 0 e o 00-buscar-feriados.py; os prompts voltam a ser 1 a 5
- Saem os slides do exemplo 05: a noite começa só com as 9 tabelas da bronze
- README: seção Aquecimento com as células para copiar

Co-Authored-By: Claude Opus 5.5 <noreply@anthropic.com>
</commit_message>
<xml_diff>
--- a/slides/pptx/Projeto Farol - Os 12 prompts.pptx
+++ b/slides/pptx/Projeto Farol - Os 12 prompts.pptx
@@ -2060,7 +2060,7 @@
         <p:spPr>
           <a:xfrm>
             <a:off x="876278" y="1582301"/>
-            <a:ext cx="2743171" cy="171446"/>
+            <a:ext cx="2053483" cy="171446"/>
           </a:xfrm>
           <a:prstGeom prst="rect">
             <a:avLst/>
@@ -2101,8 +2101,8 @@
         </p:nvSpPr>
         <p:spPr>
           <a:xfrm>
-            <a:off x="3742537" y="1582301"/>
-            <a:ext cx="885223" cy="171446"/>
+            <a:off x="3079375" y="1582301"/>
+            <a:ext cx="628499" cy="171446"/>
           </a:xfrm>
           <a:prstGeom prst="rect">
             <a:avLst/>
@@ -2143,8 +2143,8 @@
         </p:nvSpPr>
         <p:spPr>
           <a:xfrm>
-            <a:off x="4822308" y="1582301"/>
-            <a:ext cx="6752834" cy="171446"/>
+            <a:off x="3912296" y="1582301"/>
+            <a:ext cx="7699246" cy="171446"/>
           </a:xfrm>
           <a:prstGeom prst="rect">
             <a:avLst/>
@@ -2186,7 +2186,7 @@
         <p:spPr>
           <a:xfrm>
             <a:off x="761981" y="1880744"/>
-            <a:ext cx="2866259" cy="384761"/>
+            <a:ext cx="2203097" cy="384761"/>
           </a:xfrm>
           <a:prstGeom prst="rect">
             <a:avLst/>
@@ -2206,7 +2206,7 @@
         <p:spPr>
           <a:xfrm>
             <a:off x="876278" y="1982341"/>
-            <a:ext cx="2743171" cy="181566"/>
+            <a:ext cx="2053483" cy="181566"/>
           </a:xfrm>
           <a:prstGeom prst="rect">
             <a:avLst/>
@@ -2247,8 +2247,8 @@
         </p:nvSpPr>
         <p:spPr>
           <a:xfrm>
-            <a:off x="3628240" y="1880744"/>
-            <a:ext cx="1079771" cy="384761"/>
+            <a:off x="2965078" y="1880744"/>
+            <a:ext cx="832921" cy="384761"/>
           </a:xfrm>
           <a:prstGeom prst="rect">
             <a:avLst/>
@@ -2267,8 +2267,8 @@
         </p:nvSpPr>
         <p:spPr>
           <a:xfrm>
-            <a:off x="3742537" y="1982341"/>
-            <a:ext cx="885223" cy="181566"/>
+            <a:off x="3079375" y="1982341"/>
+            <a:ext cx="628499" cy="181566"/>
           </a:xfrm>
           <a:prstGeom prst="rect">
             <a:avLst/>
@@ -2309,8 +2309,8 @@
         </p:nvSpPr>
         <p:spPr>
           <a:xfrm>
-            <a:off x="4708010" y="1880744"/>
-            <a:ext cx="6721704" cy="384761"/>
+            <a:off x="3797999" y="1880744"/>
+            <a:ext cx="7631715" cy="384761"/>
           </a:xfrm>
           <a:prstGeom prst="rect">
             <a:avLst/>
@@ -2329,8 +2329,8 @@
         </p:nvSpPr>
         <p:spPr>
           <a:xfrm>
-            <a:off x="4822308" y="1982341"/>
-            <a:ext cx="6752834" cy="181566"/>
+            <a:off x="3912296" y="1982341"/>
+            <a:ext cx="7699246" cy="181566"/>
           </a:xfrm>
           <a:prstGeom prst="rect">
             <a:avLst/>
@@ -2372,7 +2372,7 @@
         <p:spPr>
           <a:xfrm>
             <a:off x="761981" y="2316303"/>
-            <a:ext cx="2866259" cy="384761"/>
+            <a:ext cx="2203097" cy="566326"/>
           </a:xfrm>
           <a:prstGeom prst="rect">
             <a:avLst/>
@@ -2392,7 +2392,7 @@
         <p:spPr>
           <a:xfrm>
             <a:off x="876278" y="2417900"/>
-            <a:ext cx="2743171" cy="181566"/>
+            <a:ext cx="2053483" cy="363132"/>
           </a:xfrm>
           <a:prstGeom prst="rect">
             <a:avLst/>
@@ -2433,8 +2433,8 @@
         </p:nvSpPr>
         <p:spPr>
           <a:xfrm>
-            <a:off x="3628240" y="2316303"/>
-            <a:ext cx="1079771" cy="384761"/>
+            <a:off x="2965078" y="2316303"/>
+            <a:ext cx="832921" cy="566326"/>
           </a:xfrm>
           <a:prstGeom prst="rect">
             <a:avLst/>
@@ -2453,8 +2453,8 @@
         </p:nvSpPr>
         <p:spPr>
           <a:xfrm>
-            <a:off x="3742537" y="2417900"/>
-            <a:ext cx="885223" cy="181566"/>
+            <a:off x="3079375" y="2417900"/>
+            <a:ext cx="628499" cy="363132"/>
           </a:xfrm>
           <a:prstGeom prst="rect">
             <a:avLst/>
@@ -2481,7 +2481,7 @@
                 <a:ea typeface="Poppins" pitchFamily="34" charset="-122"/>
                 <a:cs typeface="Poppins" pitchFamily="34" charset="-120"/>
               </a:rPr>
-              <a:t>0 a 5</a:t>
+              <a:t>1 a 5</a:t>
             </a:r>
             <a:endParaRPr lang="en-US" sz="1100" dirty="0"/>
           </a:p>
@@ -2495,8 +2495,8 @@
         </p:nvSpPr>
         <p:spPr>
           <a:xfrm>
-            <a:off x="4708010" y="2316303"/>
-            <a:ext cx="6721704" cy="384761"/>
+            <a:off x="3797999" y="2316303"/>
+            <a:ext cx="7631715" cy="566326"/>
           </a:xfrm>
           <a:prstGeom prst="rect">
             <a:avLst/>
@@ -2515,8 +2515,8 @@
         </p:nvSpPr>
         <p:spPr>
           <a:xfrm>
-            <a:off x="4822308" y="2417900"/>
-            <a:ext cx="6752834" cy="181566"/>
+            <a:off x="3912296" y="2417900"/>
+            <a:ext cx="7699246" cy="363132"/>
           </a:xfrm>
           <a:prstGeom prst="rect">
             <a:avLst/>
@@ -2543,7 +2543,7 @@
                 <a:ea typeface="Poppins" pitchFamily="34" charset="-122"/>
                 <a:cs typeface="Poppins" pitchFamily="34" charset="-120"/>
               </a:rPr>
-              <a:t>API em Python (aquecimento), bundle, silver, gold, IA no texto e métrica</a:t>
+              <a:t>bundle, silver, gold, IA no texto e métrica (antes, um aquecimento: Python no notebook buscando uma API)</a:t>
             </a:r>
             <a:endParaRPr lang="en-US" sz="1100" dirty="0"/>
           </a:p>
@@ -2557,8 +2557,8 @@
         </p:nvSpPr>
         <p:spPr>
           <a:xfrm>
-            <a:off x="761981" y="2751862"/>
-            <a:ext cx="2866259" cy="384761"/>
+            <a:off x="761981" y="2933428"/>
+            <a:ext cx="2203097" cy="384761"/>
           </a:xfrm>
           <a:prstGeom prst="rect">
             <a:avLst/>
@@ -2577,8 +2577,8 @@
         </p:nvSpPr>
         <p:spPr>
           <a:xfrm>
-            <a:off x="876278" y="2853460"/>
-            <a:ext cx="2743171" cy="181566"/>
+            <a:off x="876278" y="3035026"/>
+            <a:ext cx="2053483" cy="181566"/>
           </a:xfrm>
           <a:prstGeom prst="rect">
             <a:avLst/>
@@ -2619,8 +2619,8 @@
         </p:nvSpPr>
         <p:spPr>
           <a:xfrm>
-            <a:off x="3628240" y="2751862"/>
-            <a:ext cx="1079771" cy="384761"/>
+            <a:off x="2965078" y="2933428"/>
+            <a:ext cx="832921" cy="384761"/>
           </a:xfrm>
           <a:prstGeom prst="rect">
             <a:avLst/>
@@ -2639,8 +2639,8 @@
         </p:nvSpPr>
         <p:spPr>
           <a:xfrm>
-            <a:off x="3742537" y="2853460"/>
-            <a:ext cx="885223" cy="181566"/>
+            <a:off x="3079375" y="3035026"/>
+            <a:ext cx="628499" cy="181566"/>
           </a:xfrm>
           <a:prstGeom prst="rect">
             <a:avLst/>
@@ -2681,8 +2681,8 @@
         </p:nvSpPr>
         <p:spPr>
           <a:xfrm>
-            <a:off x="4708010" y="2751862"/>
-            <a:ext cx="6721704" cy="384761"/>
+            <a:off x="3797999" y="2933428"/>
+            <a:ext cx="7631715" cy="384761"/>
           </a:xfrm>
           <a:prstGeom prst="rect">
             <a:avLst/>
@@ -2701,8 +2701,8 @@
         </p:nvSpPr>
         <p:spPr>
           <a:xfrm>
-            <a:off x="4822308" y="2853460"/>
-            <a:ext cx="6752834" cy="181566"/>
+            <a:off x="3912296" y="3035026"/>
+            <a:ext cx="7699246" cy="181566"/>
           </a:xfrm>
           <a:prstGeom prst="rect">
             <a:avLst/>
@@ -2743,8 +2743,8 @@
         </p:nvSpPr>
         <p:spPr>
           <a:xfrm>
-            <a:off x="761981" y="3187422"/>
-            <a:ext cx="2866259" cy="384761"/>
+            <a:off x="761981" y="3368988"/>
+            <a:ext cx="2203097" cy="566326"/>
           </a:xfrm>
           <a:prstGeom prst="rect">
             <a:avLst/>
@@ -2763,8 +2763,8 @@
         </p:nvSpPr>
         <p:spPr>
           <a:xfrm>
-            <a:off x="876278" y="3289019"/>
-            <a:ext cx="2743171" cy="181566"/>
+            <a:off x="876278" y="3470585"/>
+            <a:ext cx="2053483" cy="363132"/>
           </a:xfrm>
           <a:prstGeom prst="rect">
             <a:avLst/>
@@ -2805,8 +2805,8 @@
         </p:nvSpPr>
         <p:spPr>
           <a:xfrm>
-            <a:off x="3628240" y="3187422"/>
-            <a:ext cx="1079771" cy="384761"/>
+            <a:off x="2965078" y="3368988"/>
+            <a:ext cx="832921" cy="566326"/>
           </a:xfrm>
           <a:prstGeom prst="rect">
             <a:avLst/>
@@ -2825,8 +2825,8 @@
         </p:nvSpPr>
         <p:spPr>
           <a:xfrm>
-            <a:off x="3742537" y="3289019"/>
-            <a:ext cx="885223" cy="181566"/>
+            <a:off x="3079375" y="3470585"/>
+            <a:ext cx="628499" cy="363132"/>
           </a:xfrm>
           <a:prstGeom prst="rect">
             <a:avLst/>
@@ -2867,8 +2867,8 @@
         </p:nvSpPr>
         <p:spPr>
           <a:xfrm>
-            <a:off x="4708010" y="3187422"/>
-            <a:ext cx="6721704" cy="384761"/>
+            <a:off x="3797999" y="3368988"/>
+            <a:ext cx="7631715" cy="566326"/>
           </a:xfrm>
           <a:prstGeom prst="rect">
             <a:avLst/>
@@ -2887,8 +2887,8 @@
         </p:nvSpPr>
         <p:spPr>
           <a:xfrm>
-            <a:off x="4822308" y="3289019"/>
-            <a:ext cx="6752834" cy="181566"/>
+            <a:off x="3912296" y="3470585"/>
+            <a:ext cx="7699246" cy="363132"/>
           </a:xfrm>
           <a:prstGeom prst="rect">
             <a:avLst/>
@@ -2929,7 +2929,7 @@
         </p:nvSpPr>
         <p:spPr>
           <a:xfrm>
-            <a:off x="761981" y="3724579"/>
+            <a:off x="761981" y="4087710"/>
             <a:ext cx="25399" cy="285743"/>
           </a:xfrm>
           <a:prstGeom prst="rect">
@@ -2949,7 +2949,7 @@
         </p:nvSpPr>
         <p:spPr>
           <a:xfrm>
-            <a:off x="914377" y="3762678"/>
+            <a:off x="914377" y="4125809"/>
             <a:ext cx="10935951" cy="209545"/>
           </a:xfrm>
           <a:prstGeom prst="rect">
@@ -2977,7 +2977,7 @@
                 <a:ea typeface="Poppins" pitchFamily="34" charset="-122"/>
                 <a:cs typeface="Poppins" pitchFamily="34" charset="-120"/>
               </a:rPr>
-              <a:t>O prompt 0 é o aquecimento: Python buscando uma API. Os 12 seguintes constroem a Torre, e cada um deixa algo novo no workspace.</a:t>
+              <a:t>Cada prompt deixa algo novo no workspace. Antes do primeiro, um aquecimento sem IA: Python no notebook buscando uma API.</a:t>
             </a:r>
             <a:endParaRPr lang="en-US" sz="1100" dirty="0"/>
           </a:p>

</xml_diff>